<commit_message>
feat: fix dashboard NameError/KeyError and update deliverables
</commit_message>
<xml_diff>
--- a/deliverables/05_datafolio.pptx
+++ b/deliverables/05_datafolio.pptx
@@ -5,9 +5,9 @@
     <p:sldMasterId id="2147483648" r:id="rId1"/>
   </p:sldMasterIdLst>
   <p:sldIdLst>
-    <p:sldId id="256" r:id="rId2"/>
+    <p:sldId id="256" r:id="rId7"/>
   </p:sldIdLst>
-  <p:sldSz cx="21945600" cy="32918400"/>
+  <p:sldSz cx="21945600" cy="32918400" type="screen4x3"/>
   <p:notesSz cx="6858000" cy="9144000"/>
   <p:defaultTextStyle>
     <a:defPPr>
@@ -104,22 +104,6 @@
       </a:defRPr>
     </a:lvl9pPr>
   </p:defaultTextStyle>
-  <p:extLst>
-    <p:ext uri="{EFAFB233-063F-42B5-8137-9DF3F51BA10A}">
-      <p15:sldGuideLst xmlns:p15="http://schemas.microsoft.com/office/powerpoint/2012/main">
-        <p15:guide id="1" orient="horz" pos="2160">
-          <p15:clr>
-            <a:srgbClr val="A4A3A4"/>
-          </p15:clr>
-        </p15:guide>
-        <p15:guide id="2" pos="2880">
-          <p15:clr>
-            <a:srgbClr val="A4A3A4"/>
-          </p15:clr>
-        </p15:guide>
-      </p15:sldGuideLst>
-    </p:ext>
-  </p:extLst>
 </p:presentation>
 </file>
 
@@ -161,9 +145,10 @@
           <a:lstStyle/>
           <a:p>
             <a:r>
-              <a:rPr lang="en-US"/>
+              <a:rPr lang="en-US" smtClean="0"/>
               <a:t>Click to edit Master title style</a:t>
             </a:r>
+            <a:endParaRPr lang="en-US"/>
           </a:p>
         </p:txBody>
       </p:sp>
@@ -279,9 +264,10 @@
           </a:lstStyle>
           <a:p>
             <a:r>
-              <a:rPr lang="en-US"/>
+              <a:rPr lang="en-US" smtClean="0"/>
               <a:t>Click to edit Master subtitle style</a:t>
             </a:r>
+            <a:endParaRPr lang="en-US"/>
           </a:p>
         </p:txBody>
       </p:sp>
@@ -302,7 +288,7 @@
           <a:p>
             <a:fld id="{5BCAD085-E8A6-8845-BD4E-CB4CCA059FC4}" type="datetimeFigureOut">
               <a:rPr lang="en-US" smtClean="0"/>
-              <a:t>4/11/2026</a:t>
+              <a:t>1/27/13</a:t>
             </a:fld>
             <a:endParaRPr lang="en-US"/>
           </a:p>
@@ -396,9 +382,10 @@
           <a:lstStyle/>
           <a:p>
             <a:r>
-              <a:rPr lang="en-US"/>
+              <a:rPr lang="en-US" smtClean="0"/>
               <a:t>Click to edit Master title style</a:t>
             </a:r>
+            <a:endParaRPr lang="en-US"/>
           </a:p>
         </p:txBody>
       </p:sp>
@@ -419,37 +406,38 @@
           <a:p>
             <a:pPr lvl="0"/>
             <a:r>
-              <a:rPr lang="en-US"/>
+              <a:rPr lang="en-US" smtClean="0"/>
               <a:t>Click to edit Master text styles</a:t>
             </a:r>
           </a:p>
           <a:p>
             <a:pPr lvl="1"/>
             <a:r>
-              <a:rPr lang="en-US"/>
+              <a:rPr lang="en-US" smtClean="0"/>
               <a:t>Second level</a:t>
             </a:r>
           </a:p>
           <a:p>
             <a:pPr lvl="2"/>
             <a:r>
-              <a:rPr lang="en-US"/>
+              <a:rPr lang="en-US" smtClean="0"/>
               <a:t>Third level</a:t>
             </a:r>
           </a:p>
           <a:p>
             <a:pPr lvl="3"/>
             <a:r>
-              <a:rPr lang="en-US"/>
+              <a:rPr lang="en-US" smtClean="0"/>
               <a:t>Fourth level</a:t>
             </a:r>
           </a:p>
           <a:p>
             <a:pPr lvl="4"/>
             <a:r>
-              <a:rPr lang="en-US"/>
+              <a:rPr lang="en-US" smtClean="0"/>
               <a:t>Fifth level</a:t>
             </a:r>
+            <a:endParaRPr lang="en-US"/>
           </a:p>
         </p:txBody>
       </p:sp>
@@ -470,7 +458,7 @@
           <a:p>
             <a:fld id="{5BCAD085-E8A6-8845-BD4E-CB4CCA059FC4}" type="datetimeFigureOut">
               <a:rPr lang="en-US" smtClean="0"/>
-              <a:t>4/11/2026</a:t>
+              <a:t>1/27/13</a:t>
             </a:fld>
             <a:endParaRPr lang="en-US"/>
           </a:p>
@@ -569,9 +557,10 @@
           <a:lstStyle/>
           <a:p>
             <a:r>
-              <a:rPr lang="en-US"/>
+              <a:rPr lang="en-US" smtClean="0"/>
               <a:t>Click to edit Master title style</a:t>
             </a:r>
+            <a:endParaRPr lang="en-US"/>
           </a:p>
         </p:txBody>
       </p:sp>
@@ -597,37 +586,38 @@
           <a:p>
             <a:pPr lvl="0"/>
             <a:r>
-              <a:rPr lang="en-US"/>
+              <a:rPr lang="en-US" smtClean="0"/>
               <a:t>Click to edit Master text styles</a:t>
             </a:r>
           </a:p>
           <a:p>
             <a:pPr lvl="1"/>
             <a:r>
-              <a:rPr lang="en-US"/>
+              <a:rPr lang="en-US" smtClean="0"/>
               <a:t>Second level</a:t>
             </a:r>
           </a:p>
           <a:p>
             <a:pPr lvl="2"/>
             <a:r>
-              <a:rPr lang="en-US"/>
+              <a:rPr lang="en-US" smtClean="0"/>
               <a:t>Third level</a:t>
             </a:r>
           </a:p>
           <a:p>
             <a:pPr lvl="3"/>
             <a:r>
-              <a:rPr lang="en-US"/>
+              <a:rPr lang="en-US" smtClean="0"/>
               <a:t>Fourth level</a:t>
             </a:r>
           </a:p>
           <a:p>
             <a:pPr lvl="4"/>
             <a:r>
-              <a:rPr lang="en-US"/>
+              <a:rPr lang="en-US" smtClean="0"/>
               <a:t>Fifth level</a:t>
             </a:r>
+            <a:endParaRPr lang="en-US"/>
           </a:p>
         </p:txBody>
       </p:sp>
@@ -648,7 +638,7 @@
           <a:p>
             <a:fld id="{5BCAD085-E8A6-8845-BD4E-CB4CCA059FC4}" type="datetimeFigureOut">
               <a:rPr lang="en-US" smtClean="0"/>
-              <a:t>4/11/2026</a:t>
+              <a:t>1/27/13</a:t>
             </a:fld>
             <a:endParaRPr lang="en-US"/>
           </a:p>
@@ -742,9 +732,10 @@
           <a:lstStyle/>
           <a:p>
             <a:r>
-              <a:rPr lang="en-US"/>
+              <a:rPr lang="en-US" smtClean="0"/>
               <a:t>Click to edit Master title style</a:t>
             </a:r>
+            <a:endParaRPr lang="en-US"/>
           </a:p>
         </p:txBody>
       </p:sp>
@@ -765,37 +756,38 @@
           <a:p>
             <a:pPr lvl="0"/>
             <a:r>
-              <a:rPr lang="en-US"/>
+              <a:rPr lang="en-US" smtClean="0"/>
               <a:t>Click to edit Master text styles</a:t>
             </a:r>
           </a:p>
           <a:p>
             <a:pPr lvl="1"/>
             <a:r>
-              <a:rPr lang="en-US"/>
+              <a:rPr lang="en-US" smtClean="0"/>
               <a:t>Second level</a:t>
             </a:r>
           </a:p>
           <a:p>
             <a:pPr lvl="2"/>
             <a:r>
-              <a:rPr lang="en-US"/>
+              <a:rPr lang="en-US" smtClean="0"/>
               <a:t>Third level</a:t>
             </a:r>
           </a:p>
           <a:p>
             <a:pPr lvl="3"/>
             <a:r>
-              <a:rPr lang="en-US"/>
+              <a:rPr lang="en-US" smtClean="0"/>
               <a:t>Fourth level</a:t>
             </a:r>
           </a:p>
           <a:p>
             <a:pPr lvl="4"/>
             <a:r>
-              <a:rPr lang="en-US"/>
+              <a:rPr lang="en-US" smtClean="0"/>
               <a:t>Fifth level</a:t>
             </a:r>
+            <a:endParaRPr lang="en-US"/>
           </a:p>
         </p:txBody>
       </p:sp>
@@ -816,7 +808,7 @@
           <a:p>
             <a:fld id="{5BCAD085-E8A6-8845-BD4E-CB4CCA059FC4}" type="datetimeFigureOut">
               <a:rPr lang="en-US" smtClean="0"/>
-              <a:t>4/11/2026</a:t>
+              <a:t>1/27/13</a:t>
             </a:fld>
             <a:endParaRPr lang="en-US"/>
           </a:p>
@@ -919,9 +911,10 @@
           </a:lstStyle>
           <a:p>
             <a:r>
-              <a:rPr lang="en-US"/>
+              <a:rPr lang="en-US" smtClean="0"/>
               <a:t>Click to edit Master title style</a:t>
             </a:r>
+            <a:endParaRPr lang="en-US"/>
           </a:p>
         </p:txBody>
       </p:sp>
@@ -1038,7 +1031,7 @@
           <a:p>
             <a:pPr lvl="0"/>
             <a:r>
-              <a:rPr lang="en-US"/>
+              <a:rPr lang="en-US" smtClean="0"/>
               <a:t>Click to edit Master text styles</a:t>
             </a:r>
           </a:p>
@@ -1061,7 +1054,7 @@
           <a:p>
             <a:fld id="{5BCAD085-E8A6-8845-BD4E-CB4CCA059FC4}" type="datetimeFigureOut">
               <a:rPr lang="en-US" smtClean="0"/>
-              <a:t>4/11/2026</a:t>
+              <a:t>1/27/13</a:t>
             </a:fld>
             <a:endParaRPr lang="en-US"/>
           </a:p>
@@ -1155,9 +1148,10 @@
           <a:lstStyle/>
           <a:p>
             <a:r>
-              <a:rPr lang="en-US"/>
+              <a:rPr lang="en-US" smtClean="0"/>
               <a:t>Click to edit Master title style</a:t>
             </a:r>
+            <a:endParaRPr lang="en-US"/>
           </a:p>
         </p:txBody>
       </p:sp>
@@ -1211,37 +1205,38 @@
           <a:p>
             <a:pPr lvl="0"/>
             <a:r>
-              <a:rPr lang="en-US"/>
+              <a:rPr lang="en-US" smtClean="0"/>
               <a:t>Click to edit Master text styles</a:t>
             </a:r>
           </a:p>
           <a:p>
             <a:pPr lvl="1"/>
             <a:r>
-              <a:rPr lang="en-US"/>
+              <a:rPr lang="en-US" smtClean="0"/>
               <a:t>Second level</a:t>
             </a:r>
           </a:p>
           <a:p>
             <a:pPr lvl="2"/>
             <a:r>
-              <a:rPr lang="en-US"/>
+              <a:rPr lang="en-US" smtClean="0"/>
               <a:t>Third level</a:t>
             </a:r>
           </a:p>
           <a:p>
             <a:pPr lvl="3"/>
             <a:r>
-              <a:rPr lang="en-US"/>
+              <a:rPr lang="en-US" smtClean="0"/>
               <a:t>Fourth level</a:t>
             </a:r>
           </a:p>
           <a:p>
             <a:pPr lvl="4"/>
             <a:r>
-              <a:rPr lang="en-US"/>
+              <a:rPr lang="en-US" smtClean="0"/>
               <a:t>Fifth level</a:t>
             </a:r>
+            <a:endParaRPr lang="en-US"/>
           </a:p>
         </p:txBody>
       </p:sp>
@@ -1295,37 +1290,38 @@
           <a:p>
             <a:pPr lvl="0"/>
             <a:r>
-              <a:rPr lang="en-US"/>
+              <a:rPr lang="en-US" smtClean="0"/>
               <a:t>Click to edit Master text styles</a:t>
             </a:r>
           </a:p>
           <a:p>
             <a:pPr lvl="1"/>
             <a:r>
-              <a:rPr lang="en-US"/>
+              <a:rPr lang="en-US" smtClean="0"/>
               <a:t>Second level</a:t>
             </a:r>
           </a:p>
           <a:p>
             <a:pPr lvl="2"/>
             <a:r>
-              <a:rPr lang="en-US"/>
+              <a:rPr lang="en-US" smtClean="0"/>
               <a:t>Third level</a:t>
             </a:r>
           </a:p>
           <a:p>
             <a:pPr lvl="3"/>
             <a:r>
-              <a:rPr lang="en-US"/>
+              <a:rPr lang="en-US" smtClean="0"/>
               <a:t>Fourth level</a:t>
             </a:r>
           </a:p>
           <a:p>
             <a:pPr lvl="4"/>
             <a:r>
-              <a:rPr lang="en-US"/>
+              <a:rPr lang="en-US" smtClean="0"/>
               <a:t>Fifth level</a:t>
             </a:r>
+            <a:endParaRPr lang="en-US"/>
           </a:p>
         </p:txBody>
       </p:sp>
@@ -1346,7 +1342,7 @@
           <a:p>
             <a:fld id="{5BCAD085-E8A6-8845-BD4E-CB4CCA059FC4}" type="datetimeFigureOut">
               <a:rPr lang="en-US" smtClean="0"/>
-              <a:t>4/11/2026</a:t>
+              <a:t>1/27/13</a:t>
             </a:fld>
             <a:endParaRPr lang="en-US"/>
           </a:p>
@@ -1444,9 +1440,10 @@
           </a:lstStyle>
           <a:p>
             <a:r>
-              <a:rPr lang="en-US"/>
+              <a:rPr lang="en-US" smtClean="0"/>
               <a:t>Click to edit Master title style</a:t>
             </a:r>
+            <a:endParaRPr lang="en-US"/>
           </a:p>
         </p:txBody>
       </p:sp>
@@ -1509,7 +1506,7 @@
           <a:p>
             <a:pPr lvl="0"/>
             <a:r>
-              <a:rPr lang="en-US"/>
+              <a:rPr lang="en-US" smtClean="0"/>
               <a:t>Click to edit Master text styles</a:t>
             </a:r>
           </a:p>
@@ -1565,37 +1562,38 @@
           <a:p>
             <a:pPr lvl="0"/>
             <a:r>
-              <a:rPr lang="en-US"/>
+              <a:rPr lang="en-US" smtClean="0"/>
               <a:t>Click to edit Master text styles</a:t>
             </a:r>
           </a:p>
           <a:p>
             <a:pPr lvl="1"/>
             <a:r>
-              <a:rPr lang="en-US"/>
+              <a:rPr lang="en-US" smtClean="0"/>
               <a:t>Second level</a:t>
             </a:r>
           </a:p>
           <a:p>
             <a:pPr lvl="2"/>
             <a:r>
-              <a:rPr lang="en-US"/>
+              <a:rPr lang="en-US" smtClean="0"/>
               <a:t>Third level</a:t>
             </a:r>
           </a:p>
           <a:p>
             <a:pPr lvl="3"/>
             <a:r>
-              <a:rPr lang="en-US"/>
+              <a:rPr lang="en-US" smtClean="0"/>
               <a:t>Fourth level</a:t>
             </a:r>
           </a:p>
           <a:p>
             <a:pPr lvl="4"/>
             <a:r>
-              <a:rPr lang="en-US"/>
+              <a:rPr lang="en-US" smtClean="0"/>
               <a:t>Fifth level</a:t>
             </a:r>
+            <a:endParaRPr lang="en-US"/>
           </a:p>
         </p:txBody>
       </p:sp>
@@ -1658,7 +1656,7 @@
           <a:p>
             <a:pPr lvl="0"/>
             <a:r>
-              <a:rPr lang="en-US"/>
+              <a:rPr lang="en-US" smtClean="0"/>
               <a:t>Click to edit Master text styles</a:t>
             </a:r>
           </a:p>
@@ -1714,37 +1712,38 @@
           <a:p>
             <a:pPr lvl="0"/>
             <a:r>
-              <a:rPr lang="en-US"/>
+              <a:rPr lang="en-US" smtClean="0"/>
               <a:t>Click to edit Master text styles</a:t>
             </a:r>
           </a:p>
           <a:p>
             <a:pPr lvl="1"/>
             <a:r>
-              <a:rPr lang="en-US"/>
+              <a:rPr lang="en-US" smtClean="0"/>
               <a:t>Second level</a:t>
             </a:r>
           </a:p>
           <a:p>
             <a:pPr lvl="2"/>
             <a:r>
-              <a:rPr lang="en-US"/>
+              <a:rPr lang="en-US" smtClean="0"/>
               <a:t>Third level</a:t>
             </a:r>
           </a:p>
           <a:p>
             <a:pPr lvl="3"/>
             <a:r>
-              <a:rPr lang="en-US"/>
+              <a:rPr lang="en-US" smtClean="0"/>
               <a:t>Fourth level</a:t>
             </a:r>
           </a:p>
           <a:p>
             <a:pPr lvl="4"/>
             <a:r>
-              <a:rPr lang="en-US"/>
+              <a:rPr lang="en-US" smtClean="0"/>
               <a:t>Fifth level</a:t>
             </a:r>
+            <a:endParaRPr lang="en-US"/>
           </a:p>
         </p:txBody>
       </p:sp>
@@ -1765,7 +1764,7 @@
           <a:p>
             <a:fld id="{5BCAD085-E8A6-8845-BD4E-CB4CCA059FC4}" type="datetimeFigureOut">
               <a:rPr lang="en-US" smtClean="0"/>
-              <a:t>4/11/2026</a:t>
+              <a:t>1/27/13</a:t>
             </a:fld>
             <a:endParaRPr lang="en-US"/>
           </a:p>
@@ -1859,9 +1858,10 @@
           <a:lstStyle/>
           <a:p>
             <a:r>
-              <a:rPr lang="en-US"/>
+              <a:rPr lang="en-US" smtClean="0"/>
               <a:t>Click to edit Master title style</a:t>
             </a:r>
+            <a:endParaRPr lang="en-US"/>
           </a:p>
         </p:txBody>
       </p:sp>
@@ -1882,7 +1882,7 @@
           <a:p>
             <a:fld id="{5BCAD085-E8A6-8845-BD4E-CB4CCA059FC4}" type="datetimeFigureOut">
               <a:rPr lang="en-US" smtClean="0"/>
-              <a:t>4/11/2026</a:t>
+              <a:t>1/27/13</a:t>
             </a:fld>
             <a:endParaRPr lang="en-US"/>
           </a:p>
@@ -1977,7 +1977,7 @@
           <a:p>
             <a:fld id="{5BCAD085-E8A6-8845-BD4E-CB4CCA059FC4}" type="datetimeFigureOut">
               <a:rPr lang="en-US" smtClean="0"/>
-              <a:t>4/11/2026</a:t>
+              <a:t>1/27/13</a:t>
             </a:fld>
             <a:endParaRPr lang="en-US"/>
           </a:p>
@@ -2080,9 +2080,10 @@
           </a:lstStyle>
           <a:p>
             <a:r>
-              <a:rPr lang="en-US"/>
+              <a:rPr lang="en-US" smtClean="0"/>
               <a:t>Click to edit Master title style</a:t>
             </a:r>
+            <a:endParaRPr lang="en-US"/>
           </a:p>
         </p:txBody>
       </p:sp>
@@ -2136,37 +2137,38 @@
           <a:p>
             <a:pPr lvl="0"/>
             <a:r>
-              <a:rPr lang="en-US"/>
+              <a:rPr lang="en-US" smtClean="0"/>
               <a:t>Click to edit Master text styles</a:t>
             </a:r>
           </a:p>
           <a:p>
             <a:pPr lvl="1"/>
             <a:r>
-              <a:rPr lang="en-US"/>
+              <a:rPr lang="en-US" smtClean="0"/>
               <a:t>Second level</a:t>
             </a:r>
           </a:p>
           <a:p>
             <a:pPr lvl="2"/>
             <a:r>
-              <a:rPr lang="en-US"/>
+              <a:rPr lang="en-US" smtClean="0"/>
               <a:t>Third level</a:t>
             </a:r>
           </a:p>
           <a:p>
             <a:pPr lvl="3"/>
             <a:r>
-              <a:rPr lang="en-US"/>
+              <a:rPr lang="en-US" smtClean="0"/>
               <a:t>Fourth level</a:t>
             </a:r>
           </a:p>
           <a:p>
             <a:pPr lvl="4"/>
             <a:r>
-              <a:rPr lang="en-US"/>
+              <a:rPr lang="en-US" smtClean="0"/>
               <a:t>Fifth level</a:t>
             </a:r>
+            <a:endParaRPr lang="en-US"/>
           </a:p>
         </p:txBody>
       </p:sp>
@@ -2229,7 +2231,7 @@
           <a:p>
             <a:pPr lvl="0"/>
             <a:r>
-              <a:rPr lang="en-US"/>
+              <a:rPr lang="en-US" smtClean="0"/>
               <a:t>Click to edit Master text styles</a:t>
             </a:r>
           </a:p>
@@ -2252,7 +2254,7 @@
           <a:p>
             <a:fld id="{5BCAD085-E8A6-8845-BD4E-CB4CCA059FC4}" type="datetimeFigureOut">
               <a:rPr lang="en-US" smtClean="0"/>
-              <a:t>4/11/2026</a:t>
+              <a:t>1/27/13</a:t>
             </a:fld>
             <a:endParaRPr lang="en-US"/>
           </a:p>
@@ -2355,9 +2357,10 @@
           </a:lstStyle>
           <a:p>
             <a:r>
-              <a:rPr lang="en-US"/>
+              <a:rPr lang="en-US" smtClean="0"/>
               <a:t>Click to edit Master title style</a:t>
             </a:r>
+            <a:endParaRPr lang="en-US"/>
           </a:p>
         </p:txBody>
       </p:sp>
@@ -2481,7 +2484,7 @@
           <a:p>
             <a:pPr lvl="0"/>
             <a:r>
-              <a:rPr lang="en-US"/>
+              <a:rPr lang="en-US" smtClean="0"/>
               <a:t>Click to edit Master text styles</a:t>
             </a:r>
           </a:p>
@@ -2504,7 +2507,7 @@
           <a:p>
             <a:fld id="{5BCAD085-E8A6-8845-BD4E-CB4CCA059FC4}" type="datetimeFigureOut">
               <a:rPr lang="en-US" smtClean="0"/>
-              <a:t>4/11/2026</a:t>
+              <a:t>1/27/13</a:t>
             </a:fld>
             <a:endParaRPr lang="en-US"/>
           </a:p>
@@ -2613,9 +2616,10 @@
           <a:lstStyle/>
           <a:p>
             <a:r>
-              <a:rPr lang="en-US"/>
+              <a:rPr lang="en-US" smtClean="0"/>
               <a:t>Click to edit Master title style</a:t>
             </a:r>
+            <a:endParaRPr lang="en-US"/>
           </a:p>
         </p:txBody>
       </p:sp>
@@ -2646,37 +2650,38 @@
           <a:p>
             <a:pPr lvl="0"/>
             <a:r>
-              <a:rPr lang="en-US"/>
+              <a:rPr lang="en-US" smtClean="0"/>
               <a:t>Click to edit Master text styles</a:t>
             </a:r>
           </a:p>
           <a:p>
             <a:pPr lvl="1"/>
             <a:r>
-              <a:rPr lang="en-US"/>
+              <a:rPr lang="en-US" smtClean="0"/>
               <a:t>Second level</a:t>
             </a:r>
           </a:p>
           <a:p>
             <a:pPr lvl="2"/>
             <a:r>
-              <a:rPr lang="en-US"/>
+              <a:rPr lang="en-US" smtClean="0"/>
               <a:t>Third level</a:t>
             </a:r>
           </a:p>
           <a:p>
             <a:pPr lvl="3"/>
             <a:r>
-              <a:rPr lang="en-US"/>
+              <a:rPr lang="en-US" smtClean="0"/>
               <a:t>Fourth level</a:t>
             </a:r>
           </a:p>
           <a:p>
             <a:pPr lvl="4"/>
             <a:r>
-              <a:rPr lang="en-US"/>
+              <a:rPr lang="en-US" smtClean="0"/>
               <a:t>Fifth level</a:t>
             </a:r>
+            <a:endParaRPr lang="en-US"/>
           </a:p>
         </p:txBody>
       </p:sp>
@@ -2715,7 +2720,7 @@
           <a:p>
             <a:fld id="{5BCAD085-E8A6-8845-BD4E-CB4CCA059FC4}" type="datetimeFigureOut">
               <a:rPr lang="en-US" smtClean="0"/>
-              <a:t>4/11/2026</a:t>
+              <a:t>1/27/13</a:t>
             </a:fld>
             <a:endParaRPr lang="en-US"/>
           </a:p>
@@ -3074,7 +3079,7 @@
 </file>
 
 <file path=ppt/slides/slide1.xml><?xml version="1.0" encoding="utf-8"?>
-<p:sld xmlns:a="http://schemas.openxmlformats.org/drawingml/2006/main" xmlns:r="http://schemas.openxmlformats.org/officeDocument/2006/relationships" xmlns:p="http://schemas.openxmlformats.org/presentationml/2006/main">
+<p:sld xmlns:a="http://schemas.openxmlformats.org/drawingml/2006/main" xmlns:p="http://schemas.openxmlformats.org/presentationml/2006/main" xmlns:r="http://schemas.openxmlformats.org/officeDocument/2006/relationships">
   <p:cSld>
     <p:spTree>
       <p:nvGrpSpPr>
@@ -3082,14 +3087,7 @@
         <p:cNvGrpSpPr/>
         <p:nvPr/>
       </p:nvGrpSpPr>
-      <p:grpSpPr>
-        <a:xfrm>
-          <a:off x="0" y="0"/>
-          <a:ext cx="0" cy="0"/>
-          <a:chOff x="0" y="0"/>
-          <a:chExt cx="0" cy="0"/>
-        </a:xfrm>
-      </p:grpSpPr>
+      <p:grpSpPr/>
       <p:sp>
         <p:nvSpPr>
           <p:cNvPr id="2" name="Rectangle 1"/>
@@ -3130,7 +3128,6 @@
           <a:lstStyle/>
           <a:p>
             <a:pPr algn="ctr"/>
-            <a:endParaRPr/>
           </a:p>
         </p:txBody>
       </p:sp>
@@ -3142,7 +3139,7 @@
         </p:nvSpPr>
         <p:spPr>
           <a:xfrm>
-            <a:off x="-640080" y="617220"/>
+            <a:off x="274320" y="228600"/>
             <a:ext cx="21396960" cy="1371600"/>
           </a:xfrm>
           <a:prstGeom prst="rect">
@@ -3276,7 +3273,6 @@
           <a:lstStyle/>
           <a:p>
             <a:pPr algn="ctr"/>
-            <a:endParaRPr/>
           </a:p>
         </p:txBody>
       </p:sp>
@@ -3388,7 +3384,6 @@
           <a:lstStyle/>
           <a:p>
             <a:pPr algn="ctr"/>
-            <a:endParaRPr/>
           </a:p>
         </p:txBody>
       </p:sp>
@@ -3500,7 +3495,6 @@
           <a:lstStyle/>
           <a:p>
             <a:pPr algn="ctr"/>
-            <a:endParaRPr/>
           </a:p>
         </p:txBody>
       </p:sp>
@@ -3612,7 +3606,6 @@
           <a:lstStyle/>
           <a:p>
             <a:pPr algn="ctr"/>
-            <a:endParaRPr/>
           </a:p>
         </p:txBody>
       </p:sp>
@@ -3724,7 +3717,6 @@
           <a:lstStyle/>
           <a:p>
             <a:pPr algn="ctr"/>
-            <a:endParaRPr/>
           </a:p>
         </p:txBody>
       </p:sp>
@@ -3836,7 +3828,6 @@
           <a:lstStyle/>
           <a:p>
             <a:pPr algn="ctr"/>
-            <a:endParaRPr/>
           </a:p>
         </p:txBody>
       </p:sp>
@@ -3880,7 +3871,6 @@
           <a:lstStyle/>
           <a:p>
             <a:pPr algn="ctr"/>
-            <a:endParaRPr/>
           </a:p>
         </p:txBody>
       </p:sp>
@@ -3926,7 +3916,7 @@
         </p:nvSpPr>
         <p:spPr>
           <a:xfrm>
-            <a:off x="91440" y="4846320"/>
+            <a:off x="274320" y="4846320"/>
             <a:ext cx="5040630" cy="12801600"/>
           </a:xfrm>
           <a:prstGeom prst="rect">
@@ -3963,11 +3953,14 @@
           </a:p>
           <a:p>
             <a:pPr algn="l"/>
-            <a:endParaRPr sz="950" b="0">
-              <a:solidFill>
-                <a:srgbClr val="2C3E50"/>
-              </a:solidFill>
-            </a:endParaRPr>
+            <a:r>
+              <a:rPr sz="950" b="0">
+                <a:solidFill>
+                  <a:srgbClr val="2C3E50"/>
+                </a:solidFill>
+              </a:rPr>
+              <a:t/>
+            </a:r>
           </a:p>
           <a:p>
             <a:pPr algn="l"/>
@@ -3993,11 +3986,14 @@
           </a:p>
           <a:p>
             <a:pPr algn="l"/>
-            <a:endParaRPr sz="950" b="0">
-              <a:solidFill>
-                <a:srgbClr val="2C3E50"/>
-              </a:solidFill>
-            </a:endParaRPr>
+            <a:r>
+              <a:rPr sz="950" b="0">
+                <a:solidFill>
+                  <a:srgbClr val="2C3E50"/>
+                </a:solidFill>
+              </a:rPr>
+              <a:t/>
+            </a:r>
           </a:p>
           <a:p>
             <a:pPr algn="l"/>
@@ -4056,11 +4052,14 @@
           </a:p>
           <a:p>
             <a:pPr algn="l"/>
-            <a:endParaRPr sz="950" b="0">
-              <a:solidFill>
-                <a:srgbClr val="2C3E50"/>
-              </a:solidFill>
-            </a:endParaRPr>
+            <a:r>
+              <a:rPr sz="950" b="0">
+                <a:solidFill>
+                  <a:srgbClr val="2C3E50"/>
+                </a:solidFill>
+              </a:rPr>
+              <a:t/>
+            </a:r>
           </a:p>
           <a:p>
             <a:pPr algn="l"/>
@@ -4086,11 +4085,14 @@
           </a:p>
           <a:p>
             <a:pPr algn="l"/>
-            <a:endParaRPr sz="950" b="0">
-              <a:solidFill>
-                <a:srgbClr val="2C3E50"/>
-              </a:solidFill>
-            </a:endParaRPr>
+            <a:r>
+              <a:rPr sz="950" b="0">
+                <a:solidFill>
+                  <a:srgbClr val="2C3E50"/>
+                </a:solidFill>
+              </a:rPr>
+              <a:t/>
+            </a:r>
           </a:p>
           <a:p>
             <a:pPr algn="l"/>
@@ -4111,59 +4113,62 @@
                   <a:srgbClr val="2C3E50"/>
                 </a:solidFill>
               </a:rPr>
-              <a:t>• Python 3.9+  •  scikit-learn  •  imbalanced-learn (SMOTE)</a:t>
-            </a:r>
-          </a:p>
-          <a:p>
-            <a:pPr algn="l"/>
-            <a:r>
-              <a:rPr sz="950" b="0">
-                <a:solidFill>
-                  <a:srgbClr val="2C3E50"/>
-                </a:solidFill>
-              </a:rPr>
-              <a:t>• pandas / numpy  •  matplotlib / seaborn</a:t>
-            </a:r>
-          </a:p>
-          <a:p>
-            <a:pPr algn="l"/>
-            <a:r>
-              <a:rPr sz="950" b="0">
-                <a:solidFill>
-                  <a:srgbClr val="2C3E50"/>
-                </a:solidFill>
-              </a:rPr>
-              <a:t>• SQLite (EDA queries)  •  CrewAI agents (dispatcher reports)</a:t>
-            </a:r>
-          </a:p>
-          <a:p>
-            <a:pPr algn="l"/>
-            <a:endParaRPr sz="950" b="0">
-              <a:solidFill>
-                <a:srgbClr val="2C3E50"/>
-              </a:solidFill>
-            </a:endParaRPr>
-          </a:p>
-          <a:p>
-            <a:pPr algn="l"/>
-            <a:r>
-              <a:rPr sz="950" b="0">
-                <a:solidFill>
-                  <a:srgbClr val="2C3E50"/>
-                </a:solidFill>
-              </a:rPr>
-              <a:t>Why Recall Over Accuracy</a:t>
-            </a:r>
-          </a:p>
-          <a:p>
-            <a:pPr algn="l"/>
-            <a:r>
-              <a:rPr sz="950" b="0">
-                <a:solidFill>
-                  <a:srgbClr val="2C3E50"/>
-                </a:solidFill>
-              </a:rPr>
-              <a:t>A naive classifier that always predicts "Delivered" achieves 99.3% accuracy — and catches zero failures. Recall is the business-relevant metric: each missed failure costs $17; a false alarm costs a quick manual check.</a:t>
+              <a:t>• Python / Scikit-Learn Ecosystem</a:t>
+            </a:r>
+          </a:p>
+          <a:p>
+            <a:pPr algn="l"/>
+            <a:r>
+              <a:rPr sz="950" b="0">
+                <a:solidFill>
+                  <a:srgbClr val="2C3E50"/>
+                </a:solidFill>
+              </a:rPr>
+              <a:t>• SMOTE (Imbalance Resolution)</a:t>
+            </a:r>
+          </a:p>
+          <a:p>
+            <a:pPr algn="l"/>
+            <a:r>
+              <a:rPr sz="950" b="0">
+                <a:solidFill>
+                  <a:srgbClr val="2C3E50"/>
+                </a:solidFill>
+              </a:rPr>
+              <a:t>• Executive Dashboard (Streamlit)</a:t>
+            </a:r>
+          </a:p>
+          <a:p>
+            <a:pPr algn="l"/>
+            <a:r>
+              <a:rPr sz="950" b="0">
+                <a:solidFill>
+                  <a:srgbClr val="2C3E50"/>
+                </a:solidFill>
+              </a:rPr>
+              <a:t>• Pre-dispatch Decision Layer</a:t>
+            </a:r>
+          </a:p>
+          <a:p>
+            <a:pPr algn="l"/>
+            <a:r>
+              <a:rPr sz="950" b="0">
+                <a:solidFill>
+                  <a:srgbClr val="2C3E50"/>
+                </a:solidFill>
+              </a:rPr>
+              <a:t/>
+            </a:r>
+          </a:p>
+          <a:p>
+            <a:pPr algn="l"/>
+            <a:r>
+              <a:rPr sz="950" b="0">
+                <a:solidFill>
+                  <a:srgbClr val="2C3E50"/>
+                </a:solidFill>
+              </a:rPr>
+              <a:t>Accuracy is an operational trap in high-imbalance scenarios. Predicting 'Delivered' 100% of the time yields 99.3% accuracy but zero savings. Recall is our key KPI: catching the $17 failure is the objective.</a:t>
             </a:r>
           </a:p>
         </p:txBody>
@@ -4208,7 +4213,6 @@
           <a:lstStyle/>
           <a:p>
             <a:pPr algn="ctr"/>
-            <a:endParaRPr/>
           </a:p>
         </p:txBody>
       </p:sp>
@@ -4341,7 +4345,7 @@
                   <a:srgbClr val="2C3E50"/>
                 </a:solidFill>
               </a:rPr>
-              <a:t>Locker issue flag (binary)</a:t>
+              <a:t>Short service time flag (svc &lt; 25s, binary)</a:t>
             </a:r>
           </a:p>
           <a:p>
@@ -4357,11 +4361,14 @@
           </a:p>
           <a:p>
             <a:pPr algn="l"/>
-            <a:endParaRPr sz="950" b="0">
-              <a:solidFill>
-                <a:srgbClr val="2C3E50"/>
-              </a:solidFill>
-            </a:endParaRPr>
+            <a:r>
+              <a:rPr sz="950" b="0">
+                <a:solidFill>
+                  <a:srgbClr val="2C3E50"/>
+                </a:solidFill>
+              </a:rPr>
+              <a:t/>
+            </a:r>
           </a:p>
           <a:p>
             <a:pPr algn="l"/>
@@ -4382,7 +4389,7 @@
                   <a:srgbClr val="2C3E50"/>
                 </a:solidFill>
               </a:rPr>
-              <a:t>damaged_on_arrival → IS the target (data leakage)</a:t>
+              <a:t>delivery_failed → IS the target (not a feature)</a:t>
             </a:r>
           </a:p>
           <a:p>
@@ -4449,7 +4456,6 @@
           <a:lstStyle/>
           <a:p>
             <a:pPr algn="ctr"/>
-            <a:endParaRPr/>
           </a:p>
         </p:txBody>
       </p:sp>
@@ -4521,11 +4527,14 @@
           </a:p>
           <a:p>
             <a:pPr algn="l"/>
-            <a:endParaRPr sz="950" b="0">
-              <a:solidFill>
-                <a:srgbClr val="2C3E50"/>
-              </a:solidFill>
-            </a:endParaRPr>
+            <a:r>
+              <a:rPr sz="950" b="0">
+                <a:solidFill>
+                  <a:srgbClr val="2C3E50"/>
+                </a:solidFill>
+              </a:rPr>
+              <a:t/>
+            </a:r>
           </a:p>
           <a:p>
             <a:pPr algn="l"/>
@@ -4540,11 +4549,14 @@
           </a:p>
           <a:p>
             <a:pPr algn="l"/>
-            <a:endParaRPr sz="950" b="0">
-              <a:solidFill>
-                <a:srgbClr val="2C3E50"/>
-              </a:solidFill>
-            </a:endParaRPr>
+            <a:r>
+              <a:rPr sz="950" b="0">
+                <a:solidFill>
+                  <a:srgbClr val="2C3E50"/>
+                </a:solidFill>
+              </a:rPr>
+              <a:t/>
+            </a:r>
           </a:p>
           <a:p>
             <a:pPr algn="l"/>
@@ -4632,7 +4644,6 @@
           <a:lstStyle/>
           <a:p>
             <a:pPr algn="ctr"/>
-            <a:endParaRPr/>
           </a:p>
         </p:txBody>
       </p:sp>
@@ -4676,7 +4687,6 @@
           <a:lstStyle/>
           <a:p>
             <a:pPr algn="ctr"/>
-            <a:endParaRPr/>
           </a:p>
         </p:txBody>
       </p:sp>
@@ -4938,7 +4948,6 @@
           <a:lstStyle/>
           <a:p>
             <a:pPr algn="ctr"/>
-            <a:endParaRPr/>
           </a:p>
         </p:txBody>
       </p:sp>
@@ -5010,11 +5019,14 @@
           </a:p>
           <a:p>
             <a:pPr algn="l"/>
-            <a:endParaRPr sz="950" b="0">
-              <a:solidFill>
-                <a:srgbClr val="2C3E50"/>
-              </a:solidFill>
-            </a:endParaRPr>
+            <a:r>
+              <a:rPr sz="950" b="0">
+                <a:solidFill>
+                  <a:srgbClr val="2C3E50"/>
+                </a:solidFill>
+              </a:rPr>
+              <a:t/>
+            </a:r>
           </a:p>
           <a:p>
             <a:pPr algn="l"/>
@@ -5040,11 +5052,14 @@
           </a:p>
           <a:p>
             <a:pPr algn="l"/>
-            <a:endParaRPr sz="950" b="0">
-              <a:solidFill>
-                <a:srgbClr val="2C3E50"/>
-              </a:solidFill>
-            </a:endParaRPr>
+            <a:r>
+              <a:rPr sz="950" b="0">
+                <a:solidFill>
+                  <a:srgbClr val="2C3E50"/>
+                </a:solidFill>
+              </a:rPr>
+              <a:t/>
+            </a:r>
           </a:p>
           <a:p>
             <a:pPr algn="l"/>
@@ -5070,11 +5085,14 @@
           </a:p>
           <a:p>
             <a:pPr algn="l"/>
-            <a:endParaRPr sz="950" b="0">
-              <a:solidFill>
-                <a:srgbClr val="2C3E50"/>
-              </a:solidFill>
-            </a:endParaRPr>
+            <a:r>
+              <a:rPr sz="950" b="0">
+                <a:solidFill>
+                  <a:srgbClr val="2C3E50"/>
+                </a:solidFill>
+              </a:rPr>
+              <a:t/>
+            </a:r>
           </a:p>
           <a:p>
             <a:pPr algn="l"/>
@@ -5100,11 +5118,14 @@
           </a:p>
           <a:p>
             <a:pPr algn="l"/>
-            <a:endParaRPr sz="950" b="0">
-              <a:solidFill>
-                <a:srgbClr val="2C3E50"/>
-              </a:solidFill>
-            </a:endParaRPr>
+            <a:r>
+              <a:rPr sz="950" b="0">
+                <a:solidFill>
+                  <a:srgbClr val="2C3E50"/>
+                </a:solidFill>
+              </a:rPr>
+              <a:t/>
+            </a:r>
           </a:p>
           <a:p>
             <a:pPr algn="l"/>
@@ -5170,7 +5191,6 @@
           <a:lstStyle/>
           <a:p>
             <a:pPr algn="ctr"/>
-            <a:endParaRPr/>
           </a:p>
         </p:txBody>
       </p:sp>
@@ -5242,30 +5262,36 @@
           </a:p>
           <a:p>
             <a:pPr algn="l"/>
-            <a:endParaRPr sz="950" b="0">
-              <a:solidFill>
-                <a:srgbClr val="2C3E50"/>
-              </a:solidFill>
-            </a:endParaRPr>
-          </a:p>
-          <a:p>
-            <a:pPr algn="l"/>
-            <a:r>
-              <a:rPr sz="950" b="0">
-                <a:solidFill>
-                  <a:srgbClr val="2C3E50"/>
-                </a:solidFill>
-              </a:rPr>
-              <a:t>Data leakage prevention: damaged_on_arrival IS the target variable (DELIVERY_ATTEMPTED flag from scan_status). Using it as a feature would be circular — excluded entirely.</a:t>
-            </a:r>
-          </a:p>
-          <a:p>
-            <a:pPr algn="l"/>
-            <a:endParaRPr sz="950" b="0">
-              <a:solidFill>
-                <a:srgbClr val="2C3E50"/>
-              </a:solidFill>
-            </a:endParaRPr>
+            <a:r>
+              <a:rPr sz="950" b="0">
+                <a:solidFill>
+                  <a:srgbClr val="2C3E50"/>
+                </a:solidFill>
+              </a:rPr>
+              <a:t/>
+            </a:r>
+          </a:p>
+          <a:p>
+            <a:pPr algn="l"/>
+            <a:r>
+              <a:rPr sz="950" b="0">
+                <a:solidFill>
+                  <a:srgbClr val="2C3E50"/>
+                </a:solidFill>
+              </a:rPr>
+              <a:t>Data leakage fix: locker_issue and damaged_on_arrival were conditioned on the outcome — both removed. Replaced with short_service_time (clean dispatch signal) and delivery_failed (renamed target). All artifacts retrained on clean data.</a:t>
+            </a:r>
+          </a:p>
+          <a:p>
+            <a:pPr algn="l"/>
+            <a:r>
+              <a:rPr sz="950" b="0">
+                <a:solidFill>
+                  <a:srgbClr val="2C3E50"/>
+                </a:solidFill>
+              </a:rPr>
+              <a:t/>
+            </a:r>
           </a:p>
           <a:p>
             <a:pPr algn="l"/>
@@ -5320,7 +5346,6 @@
           <a:lstStyle/>
           <a:p>
             <a:pPr algn="ctr"/>
-            <a:endParaRPr/>
           </a:p>
         </p:txBody>
       </p:sp>
@@ -5364,7 +5389,6 @@
           <a:lstStyle/>
           <a:p>
             <a:pPr algn="ctr"/>
-            <a:endParaRPr/>
           </a:p>
         </p:txBody>
       </p:sp>
@@ -5686,7 +5710,6 @@
           <a:lstStyle/>
           <a:p>
             <a:pPr algn="ctr"/>
-            <a:endParaRPr/>
           </a:p>
         </p:txBody>
       </p:sp>
@@ -5822,7 +5845,7 @@
                   <a:srgbClr val="2C3E50"/>
                 </a:solidFill>
               </a:rPr>
-              <a:t>Model-free conditional failure-rate ranking. carrier_D and morning shift emerge as the top predictors. locker_issue shows an elevated signal despite low frequency. No single feature dominates — the Random Forest will exploit interactions between carrier, shift, and distance simultaneously.</a:t>
+              <a:t>Model-free conditional failure-rate ranking. carrier_D and morning shift emerge as the top predictors. short_service_time shows an elevated signal — locker/dense-urban stops with planned service times under 25 seconds. No single feature dominates — the Random Forest exploits interactions between carrier, shift, and distance simultaneously.</a:t>
             </a:r>
           </a:p>
         </p:txBody>
@@ -5867,7 +5890,6 @@
           <a:lstStyle/>
           <a:p>
             <a:pPr algn="ctr"/>
-            <a:endParaRPr/>
           </a:p>
         </p:txBody>
       </p:sp>
@@ -6001,7 +6023,6 @@
           <a:lstStyle/>
           <a:p>
             <a:pPr algn="ctr"/>
-            <a:endParaRPr/>
           </a:p>
         </p:txBody>
       </p:sp>
@@ -6045,7 +6066,6 @@
           <a:lstStyle/>
           <a:p>
             <a:pPr algn="ctr"/>
-            <a:endParaRPr/>
           </a:p>
         </p:txBody>
       </p:sp>
@@ -6117,11 +6137,14 @@
           </a:p>
           <a:p>
             <a:pPr algn="l"/>
-            <a:endParaRPr sz="950" b="0">
-              <a:solidFill>
-                <a:srgbClr val="2C3E50"/>
-              </a:solidFill>
-            </a:endParaRPr>
+            <a:r>
+              <a:rPr sz="950" b="0">
+                <a:solidFill>
+                  <a:srgbClr val="2C3E50"/>
+                </a:solidFill>
+              </a:rPr>
+              <a:t/>
+            </a:r>
           </a:p>
           <a:p>
             <a:pPr algn="l"/>
@@ -6136,11 +6159,14 @@
           </a:p>
           <a:p>
             <a:pPr algn="l"/>
-            <a:endParaRPr sz="950" b="0">
-              <a:solidFill>
-                <a:srgbClr val="2C3E50"/>
-              </a:solidFill>
-            </a:endParaRPr>
+            <a:r>
+              <a:rPr sz="950" b="0">
+                <a:solidFill>
+                  <a:srgbClr val="2C3E50"/>
+                </a:solidFill>
+              </a:rPr>
+              <a:t/>
+            </a:r>
           </a:p>
           <a:p>
             <a:pPr algn="l"/>
@@ -6155,11 +6181,14 @@
           </a:p>
           <a:p>
             <a:pPr algn="l"/>
-            <a:endParaRPr sz="950" b="0">
-              <a:solidFill>
-                <a:srgbClr val="2C3E50"/>
-              </a:solidFill>
-            </a:endParaRPr>
+            <a:r>
+              <a:rPr sz="950" b="0">
+                <a:solidFill>
+                  <a:srgbClr val="2C3E50"/>
+                </a:solidFill>
+              </a:rPr>
+              <a:t/>
+            </a:r>
           </a:p>
           <a:p>
             <a:pPr algn="l"/>
@@ -6174,11 +6203,14 @@
           </a:p>
           <a:p>
             <a:pPr algn="l"/>
-            <a:endParaRPr sz="950" b="0">
-              <a:solidFill>
-                <a:srgbClr val="2C3E50"/>
-              </a:solidFill>
-            </a:endParaRPr>
+            <a:r>
+              <a:rPr sz="950" b="0">
+                <a:solidFill>
+                  <a:srgbClr val="2C3E50"/>
+                </a:solidFill>
+              </a:rPr>
+              <a:t/>
+            </a:r>
           </a:p>
           <a:p>
             <a:pPr algn="l"/>
@@ -6193,11 +6225,14 @@
           </a:p>
           <a:p>
             <a:pPr algn="l"/>
-            <a:endParaRPr sz="950" b="0">
-              <a:solidFill>
-                <a:srgbClr val="2C3E50"/>
-              </a:solidFill>
-            </a:endParaRPr>
+            <a:r>
+              <a:rPr sz="950" b="0">
+                <a:solidFill>
+                  <a:srgbClr val="2C3E50"/>
+                </a:solidFill>
+              </a:rPr>
+              <a:t/>
+            </a:r>
           </a:p>
           <a:p>
             <a:pPr algn="l"/>
@@ -6212,30 +6247,36 @@
           </a:p>
           <a:p>
             <a:pPr algn="l"/>
-            <a:endParaRPr sz="950" b="0">
-              <a:solidFill>
-                <a:srgbClr val="2C3E50"/>
-              </a:solidFill>
-            </a:endParaRPr>
-          </a:p>
-          <a:p>
-            <a:pPr algn="l"/>
-            <a:r>
-              <a:rPr sz="950" b="0">
-                <a:solidFill>
-                  <a:srgbClr val="2C3E50"/>
-                </a:solidFill>
-              </a:rPr>
-              <a:t>3. Implement a morning-shift access-verification protocol: confirm delivery access codes, intercom numbers, or locker availability before dispatch for packages on sub-40 km urban routes.</a:t>
-            </a:r>
-          </a:p>
-          <a:p>
-            <a:pPr algn="l"/>
-            <a:endParaRPr sz="950" b="0">
-              <a:solidFill>
-                <a:srgbClr val="2C3E50"/>
-              </a:solidFill>
-            </a:endParaRPr>
+            <a:r>
+              <a:rPr sz="950" b="0">
+                <a:solidFill>
+                  <a:srgbClr val="2C3E50"/>
+                </a:solidFill>
+              </a:rPr>
+              <a:t/>
+            </a:r>
+          </a:p>
+          <a:p>
+            <a:pPr algn="l"/>
+            <a:r>
+              <a:rPr sz="950" b="0">
+                <a:solidFill>
+                  <a:srgbClr val="2C3E50"/>
+                </a:solidFill>
+              </a:rPr>
+              <a:t>3. PREVENTIVE ACCESS PROTOCOL: For high-risk urban routes, implement a 07:00 Access-Verification protocol. Resolving gate codes and intercom issues before dispatch addresses the Urban Density Paradox at the source.</a:t>
+            </a:r>
+          </a:p>
+          <a:p>
+            <a:pPr algn="l"/>
+            <a:r>
+              <a:rPr sz="950" b="0">
+                <a:solidFill>
+                  <a:srgbClr val="2C3E50"/>
+                </a:solidFill>
+              </a:rPr>
+              <a:t/>
+            </a:r>
           </a:p>
         </p:txBody>
       </p:sp>
@@ -6279,7 +6320,6 @@
           <a:lstStyle/>
           <a:p>
             <a:pPr algn="ctr"/>
-            <a:endParaRPr/>
           </a:p>
         </p:txBody>
       </p:sp>
@@ -6362,11 +6402,14 @@
           </a:p>
           <a:p>
             <a:pPr algn="l"/>
-            <a:endParaRPr sz="950" b="0">
-              <a:solidFill>
-                <a:srgbClr val="2C3E50"/>
-              </a:solidFill>
-            </a:endParaRPr>
+            <a:r>
+              <a:rPr sz="950" b="0">
+                <a:solidFill>
+                  <a:srgbClr val="2C3E50"/>
+                </a:solidFill>
+              </a:rPr>
+              <a:t/>
+            </a:r>
           </a:p>
           <a:p>
             <a:pPr algn="l"/>
@@ -6392,11 +6435,14 @@
           </a:p>
           <a:p>
             <a:pPr algn="l"/>
-            <a:endParaRPr sz="950" b="0">
-              <a:solidFill>
-                <a:srgbClr val="2C3E50"/>
-              </a:solidFill>
-            </a:endParaRPr>
+            <a:r>
+              <a:rPr sz="950" b="0">
+                <a:solidFill>
+                  <a:srgbClr val="2C3E50"/>
+                </a:solidFill>
+              </a:rPr>
+              <a:t/>
+            </a:r>
           </a:p>
           <a:p>
             <a:pPr algn="l"/>
@@ -6422,11 +6468,14 @@
           </a:p>
           <a:p>
             <a:pPr algn="l"/>
-            <a:endParaRPr sz="950" b="0">
-              <a:solidFill>
-                <a:srgbClr val="2C3E50"/>
-              </a:solidFill>
-            </a:endParaRPr>
+            <a:r>
+              <a:rPr sz="950" b="0">
+                <a:solidFill>
+                  <a:srgbClr val="2C3E50"/>
+                </a:solidFill>
+              </a:rPr>
+              <a:t/>
+            </a:r>
           </a:p>
           <a:p>
             <a:pPr algn="l"/>
@@ -6452,11 +6501,14 @@
           </a:p>
           <a:p>
             <a:pPr algn="l"/>
-            <a:endParaRPr sz="950" b="0">
-              <a:solidFill>
-                <a:srgbClr val="2C3E50"/>
-              </a:solidFill>
-            </a:endParaRPr>
+            <a:r>
+              <a:rPr sz="950" b="0">
+                <a:solidFill>
+                  <a:srgbClr val="2C3E50"/>
+                </a:solidFill>
+              </a:rPr>
+              <a:t/>
+            </a:r>
           </a:p>
           <a:p>
             <a:pPr algn="l"/>
@@ -6544,7 +6596,6 @@
           <a:lstStyle/>
           <a:p>
             <a:pPr algn="ctr"/>
-            <a:endParaRPr/>
           </a:p>
         </p:txBody>
       </p:sp>
@@ -6627,41 +6678,47 @@
           </a:p>
           <a:p>
             <a:pPr algn="l"/>
-            <a:endParaRPr sz="950" b="0">
-              <a:solidFill>
-                <a:srgbClr val="2C3E50"/>
-              </a:solidFill>
-            </a:endParaRPr>
-          </a:p>
-          <a:p>
-            <a:pPr algn="l"/>
-            <a:r>
-              <a:rPr sz="950" b="0">
-                <a:solidFill>
-                  <a:srgbClr val="2C3E50"/>
-                </a:solidFill>
-              </a:rPr>
-              <a:t>Barcelona Open Data Validation Layer</a:t>
-            </a:r>
-          </a:p>
-          <a:p>
-            <a:pPr algn="l"/>
-            <a:r>
-              <a:rPr sz="950" b="0">
-                <a:solidFill>
-                  <a:srgbClr val="2C3E50"/>
-                </a:solidFill>
-              </a:rPr>
-              <a:t>A planned extension would test whether urban-density failure patterns generalize to other markets using Barcelona Open Data (accident risk by neighborhood, traffic congestion by shift). This would validate whether the U.S.-specific findings translate to European delivery networks.</a:t>
-            </a:r>
-          </a:p>
-          <a:p>
-            <a:pPr algn="l"/>
-            <a:endParaRPr sz="950" b="0">
-              <a:solidFill>
-                <a:srgbClr val="2C3E50"/>
-              </a:solidFill>
-            </a:endParaRPr>
+            <a:r>
+              <a:rPr sz="950" b="0">
+                <a:solidFill>
+                  <a:srgbClr val="2C3E50"/>
+                </a:solidFill>
+              </a:rPr>
+              <a:t/>
+            </a:r>
+          </a:p>
+          <a:p>
+            <a:pPr algn="l"/>
+            <a:r>
+              <a:rPr sz="950" b="0">
+                <a:solidFill>
+                  <a:srgbClr val="2C3E50"/>
+                </a:solidFill>
+              </a:rPr>
+              <a:t>Multi-city Validation Layer</a:t>
+            </a:r>
+          </a:p>
+          <a:p>
+            <a:pPr algn="l"/>
+            <a:r>
+              <a:rPr sz="950" b="0">
+                <a:solidFill>
+                  <a:srgbClr val="2C3E50"/>
+                </a:solidFill>
+              </a:rPr>
+              <a:t>A planned extension would test whether urban-density failure patterns generalize to other markets within the full LMRC dataset (Seattle, Chicago, and Boston). This would validate whether the U.S.-specific findings translate across different operational environments.</a:t>
+            </a:r>
+          </a:p>
+          <a:p>
+            <a:pPr algn="l"/>
+            <a:r>
+              <a:rPr sz="950" b="0">
+                <a:solidFill>
+                  <a:srgbClr val="2C3E50"/>
+                </a:solidFill>
+              </a:rPr>
+              <a:t/>
+            </a:r>
           </a:p>
           <a:p>
             <a:pPr algn="l"/>
@@ -6687,11 +6744,14 @@
           </a:p>
           <a:p>
             <a:pPr algn="l"/>
-            <a:endParaRPr sz="950" b="0">
-              <a:solidFill>
-                <a:srgbClr val="2C3E50"/>
-              </a:solidFill>
-            </a:endParaRPr>
+            <a:r>
+              <a:rPr sz="950" b="0">
+                <a:solidFill>
+                  <a:srgbClr val="2C3E50"/>
+                </a:solidFill>
+              </a:rPr>
+              <a:t/>
+            </a:r>
           </a:p>
           <a:p>
             <a:pPr algn="l"/>
@@ -6757,7 +6817,6 @@
           <a:lstStyle/>
           <a:p>
             <a:pPr algn="ctr"/>
-            <a:endParaRPr/>
           </a:p>
         </p:txBody>
       </p:sp>
@@ -6913,7 +6972,6 @@
           <a:lstStyle/>
           <a:p>
             <a:pPr algn="ctr"/>
-            <a:endParaRPr/>
           </a:p>
         </p:txBody>
       </p:sp>
@@ -6926,7 +6984,7 @@
         <p:spPr>
           <a:xfrm>
             <a:off x="274320" y="32598360"/>
-            <a:ext cx="21396959" cy="215444"/>
+            <a:ext cx="21396960" cy="274320"/>
           </a:xfrm>
           <a:prstGeom prst="rect">
             <a:avLst/>

</xml_diff>